<commit_message>
feat: finaliza as 4 paginas do dashboard (Visao Executiva, Performance Sellers, Logistica, Geografia)
</commit_message>
<xml_diff>
--- a/powerbi/olist_dashboard_layout.pptx
+++ b/powerbi/olist_dashboard_layout.pptx
@@ -12,7 +12,7 @@
     <p:sldId id="272" r:id="rId3"/>
     <p:sldId id="280" r:id="rId4"/>
     <p:sldId id="277" r:id="rId5"/>
-    <p:sldId id="278" r:id="rId6"/>
+    <p:sldId id="281" r:id="rId6"/>
   </p:sldIdLst>
   <p:sldSz cx="12192000" cy="6858000"/>
   <p:notesSz cx="6858000" cy="12192000"/>
@@ -121,7 +121,7 @@
             <p14:sldId id="272"/>
             <p14:sldId id="280"/>
             <p14:sldId id="277"/>
-            <p14:sldId id="278"/>
+            <p14:sldId id="281"/>
           </p14:sldIdLst>
         </p14:section>
       </p14:sectionLst>
@@ -136,9 +136,100 @@
 <file path=ppt/revisionInfo.xml><?xml version="1.0" encoding="utf-8"?>
 <p1510:revInfo xmlns:a="http://schemas.openxmlformats.org/drawingml/2006/main" xmlns:r="http://schemas.openxmlformats.org/officeDocument/2006/relationships" xmlns:p1510="http://schemas.microsoft.com/office/powerpoint/2015/10/main">
   <p1510:revLst>
-    <p1510:client id="{4160E14B-1BC0-46CB-B723-42DD4143EEEA}" v="2" dt="2026-08-06T21:22:29.437"/>
+    <p1510:client id="{4160E14B-1BC0-46CB-B723-42DD4143EEEA}" v="3" dt="2026-08-10T21:28:32.582"/>
   </p1510:revLst>
 </p1510:revInfo>
+</file>
+
+<file path=ppt/changesInfos/changesInfo1.xml><?xml version="1.0" encoding="utf-8"?>
+<pc:chgInfo xmlns:a="http://schemas.openxmlformats.org/drawingml/2006/main" xmlns:r="http://schemas.openxmlformats.org/officeDocument/2006/relationships" xmlns:ac="http://schemas.microsoft.com/office/drawing/2013/main/command" xmlns:pc="http://schemas.microsoft.com/office/powerpoint/2013/main/command">
+  <pc:docChgLst>
+    <pc:chgData name="Eloisa Ribeiro de Almeida" userId="32211d8e-657b-483a-ac5b-f27b22c55da2" providerId="ADAL" clId="{3D6911B2-E78D-40A2-A9A6-F6FA27D0B797}"/>
+    <pc:docChg chg="custSel addSld delSld modSld modSection">
+      <pc:chgData name="Eloisa Ribeiro de Almeida" userId="32211d8e-657b-483a-ac5b-f27b22c55da2" providerId="ADAL" clId="{3D6911B2-E78D-40A2-A9A6-F6FA27D0B797}" dt="2026-08-10T21:37:41.784" v="80" actId="478"/>
+      <pc:docMkLst>
+        <pc:docMk/>
+      </pc:docMkLst>
+      <pc:sldChg chg="modSp mod">
+        <pc:chgData name="Eloisa Ribeiro de Almeida" userId="32211d8e-657b-483a-ac5b-f27b22c55da2" providerId="ADAL" clId="{3D6911B2-E78D-40A2-A9A6-F6FA27D0B797}" dt="2026-08-10T20:57:34.227" v="72" actId="20577"/>
+        <pc:sldMkLst>
+          <pc:docMk/>
+          <pc:sldMk cId="1379572456" sldId="277"/>
+        </pc:sldMkLst>
+        <pc:spChg chg="mod">
+          <ac:chgData name="Eloisa Ribeiro de Almeida" userId="32211d8e-657b-483a-ac5b-f27b22c55da2" providerId="ADAL" clId="{3D6911B2-E78D-40A2-A9A6-F6FA27D0B797}" dt="2026-08-10T20:51:26.808" v="69" actId="20577"/>
+          <ac:spMkLst>
+            <pc:docMk/>
+            <pc:sldMk cId="1379572456" sldId="277"/>
+            <ac:spMk id="38" creationId="{8694267B-6AB2-D2CF-39D2-248AD48DCBD4}"/>
+          </ac:spMkLst>
+        </pc:spChg>
+        <pc:spChg chg="mod">
+          <ac:chgData name="Eloisa Ribeiro de Almeida" userId="32211d8e-657b-483a-ac5b-f27b22c55da2" providerId="ADAL" clId="{3D6911B2-E78D-40A2-A9A6-F6FA27D0B797}" dt="2026-08-10T20:57:34.227" v="72" actId="20577"/>
+          <ac:spMkLst>
+            <pc:docMk/>
+            <pc:sldMk cId="1379572456" sldId="277"/>
+            <ac:spMk id="41" creationId="{65154500-2A59-834A-5B8F-10A50BF9FC84}"/>
+          </ac:spMkLst>
+        </pc:spChg>
+        <pc:grpChg chg="mod">
+          <ac:chgData name="Eloisa Ribeiro de Almeida" userId="32211d8e-657b-483a-ac5b-f27b22c55da2" providerId="ADAL" clId="{3D6911B2-E78D-40A2-A9A6-F6FA27D0B797}" dt="2026-08-10T20:50:57.091" v="41" actId="14100"/>
+          <ac:grpSpMkLst>
+            <pc:docMk/>
+            <pc:sldMk cId="1379572456" sldId="277"/>
+            <ac:grpSpMk id="36" creationId="{969166FB-7819-1F11-A481-CA7FDCF6A074}"/>
+          </ac:grpSpMkLst>
+        </pc:grpChg>
+        <pc:grpChg chg="mod">
+          <ac:chgData name="Eloisa Ribeiro de Almeida" userId="32211d8e-657b-483a-ac5b-f27b22c55da2" providerId="ADAL" clId="{3D6911B2-E78D-40A2-A9A6-F6FA27D0B797}" dt="2026-08-10T20:50:59.708" v="42" actId="14100"/>
+          <ac:grpSpMkLst>
+            <pc:docMk/>
+            <pc:sldMk cId="1379572456" sldId="277"/>
+            <ac:grpSpMk id="39" creationId="{099BE0B6-C68E-721F-9885-5F6B1ACA5F0F}"/>
+          </ac:grpSpMkLst>
+        </pc:grpChg>
+      </pc:sldChg>
+      <pc:sldChg chg="modSp del mod">
+        <pc:chgData name="Eloisa Ribeiro de Almeida" userId="32211d8e-657b-483a-ac5b-f27b22c55da2" providerId="ADAL" clId="{3D6911B2-E78D-40A2-A9A6-F6FA27D0B797}" dt="2026-08-10T21:30:45.694" v="78"/>
+        <pc:sldMkLst>
+          <pc:docMk/>
+          <pc:sldMk cId="4254914698" sldId="278"/>
+        </pc:sldMkLst>
+        <pc:spChg chg="mod">
+          <ac:chgData name="Eloisa Ribeiro de Almeida" userId="32211d8e-657b-483a-ac5b-f27b22c55da2" providerId="ADAL" clId="{3D6911B2-E78D-40A2-A9A6-F6FA27D0B797}" dt="2026-08-10T21:22:00.630" v="76" actId="108"/>
+          <ac:spMkLst>
+            <pc:docMk/>
+            <pc:sldMk cId="4254914698" sldId="278"/>
+            <ac:spMk id="41" creationId="{9CF7D3CE-D179-07E5-F68B-6388205D9873}"/>
+          </ac:spMkLst>
+        </pc:spChg>
+      </pc:sldChg>
+      <pc:sldChg chg="delSp add mod">
+        <pc:chgData name="Eloisa Ribeiro de Almeida" userId="32211d8e-657b-483a-ac5b-f27b22c55da2" providerId="ADAL" clId="{3D6911B2-E78D-40A2-A9A6-F6FA27D0B797}" dt="2026-08-10T21:37:41.784" v="80" actId="478"/>
+        <pc:sldMkLst>
+          <pc:docMk/>
+          <pc:sldMk cId="2173601608" sldId="281"/>
+        </pc:sldMkLst>
+        <pc:spChg chg="del">
+          <ac:chgData name="Eloisa Ribeiro de Almeida" userId="32211d8e-657b-483a-ac5b-f27b22c55da2" providerId="ADAL" clId="{3D6911B2-E78D-40A2-A9A6-F6FA27D0B797}" dt="2026-08-10T21:37:38.445" v="79" actId="478"/>
+          <ac:spMkLst>
+            <pc:docMk/>
+            <pc:sldMk cId="2173601608" sldId="281"/>
+            <ac:spMk id="20" creationId="{32A49B13-A956-0E96-79F4-A7424AE665B3}"/>
+          </ac:spMkLst>
+        </pc:spChg>
+        <pc:spChg chg="del">
+          <ac:chgData name="Eloisa Ribeiro de Almeida" userId="32211d8e-657b-483a-ac5b-f27b22c55da2" providerId="ADAL" clId="{3D6911B2-E78D-40A2-A9A6-F6FA27D0B797}" dt="2026-08-10T21:37:41.784" v="80" actId="478"/>
+          <ac:spMkLst>
+            <pc:docMk/>
+            <pc:sldMk cId="2173601608" sldId="281"/>
+            <ac:spMk id="21" creationId="{6BA3CCBD-58BD-8557-CA42-8B3F2F9893BD}"/>
+          </ac:spMkLst>
+        </pc:spChg>
+      </pc:sldChg>
+    </pc:docChg>
+  </pc:docChgLst>
+</pc:chgInfo>
 </file>
 
 <file path=ppt/notesMasters/notesMaster1.xml><?xml version="1.0" encoding="utf-8"?>
@@ -6898,7 +6989,11 @@
                 <a:t>Prazo</a:t>
               </a:r>
               <a:endParaRPr lang="en-US" sz="1200" dirty="0">
+                <a:solidFill>
+                  <a:srgbClr val="1E1F22"/>
+                </a:solidFill>
                 <a:latin typeface="Segoe UI Light" panose="020B0502040204020203" pitchFamily="34" charset="0"/>
+                <a:ea typeface="Segoe UI" pitchFamily="34" charset="-122"/>
                 <a:cs typeface="Segoe UI Light" panose="020B0502040204020203" pitchFamily="34" charset="0"/>
               </a:endParaRPr>
             </a:p>
@@ -6958,7 +7053,7 @@
         <p:grpSpPr>
           <a:xfrm>
             <a:off x="2377440" y="3708400"/>
-            <a:ext cx="4894655" cy="2870200"/>
+            <a:ext cx="4520474" cy="2870200"/>
             <a:chOff x="2368956" y="4864608"/>
             <a:chExt cx="4669384" cy="1719072"/>
           </a:xfrm>
@@ -7032,54 +7127,20 @@
             <a:bodyPr wrap="square" lIns="0" tIns="0" rIns="0" bIns="0" rtlCol="0" anchor="ctr"/>
             <a:lstStyle/>
             <a:p>
-              <a:pPr marL="0" indent="0">
-                <a:buNone/>
-              </a:pPr>
               <a:r>
-                <a:rPr lang="en-US" sz="1200" dirty="0" err="1">
+                <a:rPr lang="pt-BR" sz="1200" dirty="0">
                   <a:solidFill>
                     <a:srgbClr val="1E1F22"/>
                   </a:solidFill>
                   <a:latin typeface="Segoe UI Light" panose="020B0502040204020203" pitchFamily="34" charset="0"/>
-                  <a:ea typeface="Segoe UI" pitchFamily="34" charset="-122"/>
                   <a:cs typeface="Segoe UI Light" panose="020B0502040204020203" pitchFamily="34" charset="0"/>
                 </a:rPr>
-                <a:t>Prazo</a:t>
-              </a:r>
-              <a:r>
-                <a:rPr lang="en-US" sz="1200" dirty="0">
-                  <a:solidFill>
-                    <a:srgbClr val="1E1F22"/>
-                  </a:solidFill>
-                  <a:latin typeface="Segoe UI Light" panose="020B0502040204020203" pitchFamily="34" charset="0"/>
-                  <a:ea typeface="Segoe UI" pitchFamily="34" charset="-122"/>
-                  <a:cs typeface="Segoe UI Light" panose="020B0502040204020203" pitchFamily="34" charset="0"/>
-                </a:rPr>
-                <a:t> </a:t>
-              </a:r>
-              <a:r>
-                <a:rPr lang="en-US" sz="1200" dirty="0" err="1">
-                  <a:solidFill>
-                    <a:srgbClr val="1E1F22"/>
-                  </a:solidFill>
-                  <a:latin typeface="Segoe UI Light" panose="020B0502040204020203" pitchFamily="34" charset="0"/>
-                  <a:ea typeface="Segoe UI" pitchFamily="34" charset="-122"/>
-                  <a:cs typeface="Segoe UI Light" panose="020B0502040204020203" pitchFamily="34" charset="0"/>
-                </a:rPr>
-                <a:t>Médio</a:t>
-              </a:r>
-              <a:r>
-                <a:rPr lang="en-US" sz="1200" dirty="0">
-                  <a:solidFill>
-                    <a:srgbClr val="1E1F22"/>
-                  </a:solidFill>
-                  <a:latin typeface="Segoe UI Light" panose="020B0502040204020203" pitchFamily="34" charset="0"/>
-                  <a:ea typeface="Segoe UI" pitchFamily="34" charset="-122"/>
-                  <a:cs typeface="Segoe UI Light" panose="020B0502040204020203" pitchFamily="34" charset="0"/>
-                </a:rPr>
-                <a:t> de Entrega</a:t>
+                <a:t>Evolução do Prazo Médio de Entrega</a:t>
               </a:r>
               <a:endParaRPr lang="en-US" sz="1200" dirty="0">
+                <a:solidFill>
+                  <a:srgbClr val="1E1F22"/>
+                </a:solidFill>
                 <a:latin typeface="Segoe UI Light" panose="020B0502040204020203" pitchFamily="34" charset="0"/>
                 <a:cs typeface="Segoe UI Light" panose="020B0502040204020203" pitchFamily="34" charset="0"/>
               </a:endParaRPr>
@@ -7139,8 +7200,8 @@
         </p:nvGrpSpPr>
         <p:grpSpPr>
           <a:xfrm>
-            <a:off x="7430770" y="3708400"/>
-            <a:ext cx="4478020" cy="2870200"/>
+            <a:off x="7082756" y="3708400"/>
+            <a:ext cx="4826033" cy="2870200"/>
             <a:chOff x="7247992" y="4864608"/>
             <a:chExt cx="4660900" cy="1719072"/>
           </a:xfrm>
@@ -8130,90 +8191,6 @@
           </a:p>
         </p:txBody>
       </p:sp>
-      <p:sp>
-        <p:nvSpPr>
-          <p:cNvPr id="20" name="Shape 18">
-            <a:extLst>
-              <a:ext uri="{FF2B5EF4-FFF2-40B4-BE49-F238E27FC236}">
-                <a16:creationId xmlns:a16="http://schemas.microsoft.com/office/drawing/2014/main" id="{32A49B13-A956-0E96-79F4-A7424AE665B3}"/>
-              </a:ext>
-            </a:extLst>
-          </p:cNvPr>
-          <p:cNvSpPr/>
-          <p:nvPr/>
-        </p:nvSpPr>
-        <p:spPr>
-          <a:xfrm>
-            <a:off x="10424160" y="292608"/>
-            <a:ext cx="1463040" cy="384048"/>
-          </a:xfrm>
-          <a:prstGeom prst="roundRect">
-            <a:avLst>
-              <a:gd name="adj" fmla="val 19048"/>
-            </a:avLst>
-          </a:prstGeom>
-          <a:solidFill>
-            <a:srgbClr val="FFFFFF"/>
-          </a:solidFill>
-          <a:ln w="12700">
-            <a:solidFill>
-              <a:srgbClr val="B8B9BD"/>
-            </a:solidFill>
-          </a:ln>
-        </p:spPr>
-        <p:txBody>
-          <a:bodyPr/>
-          <a:lstStyle/>
-          <a:p>
-            <a:endParaRPr lang="pt-BR"/>
-          </a:p>
-        </p:txBody>
-      </p:sp>
-      <p:sp>
-        <p:nvSpPr>
-          <p:cNvPr id="21" name="Text 19">
-            <a:extLst>
-              <a:ext uri="{FF2B5EF4-FFF2-40B4-BE49-F238E27FC236}">
-                <a16:creationId xmlns:a16="http://schemas.microsoft.com/office/drawing/2014/main" id="{6BA3CCBD-58BD-8557-CA42-8B3F2F9893BD}"/>
-              </a:ext>
-            </a:extLst>
-          </p:cNvPr>
-          <p:cNvSpPr/>
-          <p:nvPr/>
-        </p:nvSpPr>
-        <p:spPr>
-          <a:xfrm>
-            <a:off x="10424160" y="292608"/>
-            <a:ext cx="1463040" cy="384048"/>
-          </a:xfrm>
-          <a:prstGeom prst="rect">
-            <a:avLst/>
-          </a:prstGeom>
-          <a:noFill/>
-          <a:ln/>
-        </p:spPr>
-        <p:txBody>
-          <a:bodyPr wrap="square" lIns="0" tIns="0" rIns="0" bIns="0" rtlCol="0" anchor="ctr"/>
-          <a:lstStyle/>
-          <a:p>
-            <a:pPr marL="0" indent="0" algn="ctr">
-              <a:buNone/>
-            </a:pPr>
-            <a:r>
-              <a:rPr lang="en-US" sz="1100" dirty="0">
-                <a:solidFill>
-                  <a:srgbClr val="1E1F22"/>
-                </a:solidFill>
-                <a:latin typeface="Segoe UI" pitchFamily="34" charset="0"/>
-                <a:ea typeface="Segoe UI" pitchFamily="34" charset="-122"/>
-                <a:cs typeface="Segoe UI" pitchFamily="34" charset="-120"/>
-              </a:rPr>
-              <a:t>Filtros  ▾</a:t>
-            </a:r>
-            <a:endParaRPr lang="en-US" sz="1100" dirty="0"/>
-          </a:p>
-        </p:txBody>
-      </p:sp>
       <p:grpSp>
         <p:nvGrpSpPr>
           <p:cNvPr id="30" name="Agrupar 29">
@@ -8228,8 +8205,8 @@
         </p:nvGrpSpPr>
         <p:grpSpPr>
           <a:xfrm>
-            <a:off x="2377440" y="736600"/>
-            <a:ext cx="4716626" cy="2870200"/>
+            <a:off x="2374900" y="1930400"/>
+            <a:ext cx="4673600" cy="2540000"/>
             <a:chOff x="2377440" y="2331720"/>
             <a:chExt cx="6492240" cy="2331720"/>
           </a:xfrm>
@@ -8410,8 +8387,8 @@
         </p:nvGrpSpPr>
         <p:grpSpPr>
           <a:xfrm>
-            <a:off x="7235190" y="736600"/>
-            <a:ext cx="4673479" cy="2870200"/>
+            <a:off x="7226300" y="1930400"/>
+            <a:ext cx="4699000" cy="2540000"/>
             <a:chOff x="9070848" y="2348382"/>
             <a:chExt cx="2846527" cy="2331933"/>
           </a:xfrm>
@@ -8581,8 +8558,8 @@
         </p:nvGrpSpPr>
         <p:grpSpPr>
           <a:xfrm>
-            <a:off x="2377440" y="3708400"/>
-            <a:ext cx="9518244" cy="2870200"/>
+            <a:off x="2374900" y="4648200"/>
+            <a:ext cx="9550400" cy="1930400"/>
             <a:chOff x="2368956" y="4837556"/>
             <a:chExt cx="4669384" cy="1746124"/>
           </a:xfrm>
@@ -8656,43 +8633,20 @@
             <a:bodyPr wrap="square" lIns="0" tIns="0" rIns="0" bIns="0" rtlCol="0" anchor="ctr"/>
             <a:lstStyle/>
             <a:p>
-              <a:pPr marL="0" indent="0">
-                <a:buNone/>
-              </a:pPr>
               <a:r>
-                <a:rPr lang="en-US" sz="1200" dirty="0" err="1">
+                <a:rPr lang="pt-BR" sz="1200" dirty="0">
                   <a:solidFill>
                     <a:srgbClr val="1E1F22"/>
                   </a:solidFill>
                   <a:latin typeface="Segoe UI Light" panose="020B0502040204020203" pitchFamily="34" charset="0"/>
-                  <a:ea typeface="Segoe UI" pitchFamily="34" charset="-122"/>
                   <a:cs typeface="Segoe UI Light" panose="020B0502040204020203" pitchFamily="34" charset="0"/>
                 </a:rPr>
-                <a:t>Oportunidades</a:t>
-              </a:r>
-              <a:r>
-                <a:rPr lang="en-US" sz="1200" dirty="0">
-                  <a:solidFill>
-                    <a:srgbClr val="1E1F22"/>
-                  </a:solidFill>
-                  <a:latin typeface="Segoe UI Light" panose="020B0502040204020203" pitchFamily="34" charset="0"/>
-                  <a:ea typeface="Segoe UI" pitchFamily="34" charset="-122"/>
-                  <a:cs typeface="Segoe UI Light" panose="020B0502040204020203" pitchFamily="34" charset="0"/>
-                </a:rPr>
-                <a:t> de </a:t>
-              </a:r>
-              <a:r>
-                <a:rPr lang="en-US" sz="1200" dirty="0" err="1">
-                  <a:solidFill>
-                    <a:srgbClr val="1E1F22"/>
-                  </a:solidFill>
-                  <a:latin typeface="Segoe UI Light" panose="020B0502040204020203" pitchFamily="34" charset="0"/>
-                  <a:ea typeface="Segoe UI" pitchFamily="34" charset="-122"/>
-                  <a:cs typeface="Segoe UI Light" panose="020B0502040204020203" pitchFamily="34" charset="0"/>
-                </a:rPr>
-                <a:t>Expansão</a:t>
+                <a:t>Sellers x Receita por Estado — Oportunidade de Expansão</a:t>
               </a:r>
               <a:endParaRPr lang="en-US" sz="1200" dirty="0">
+                <a:solidFill>
+                  <a:srgbClr val="1E1F22"/>
+                </a:solidFill>
                 <a:latin typeface="Segoe UI Light" panose="020B0502040204020203" pitchFamily="34" charset="0"/>
                 <a:cs typeface="Segoe UI Light" panose="020B0502040204020203" pitchFamily="34" charset="0"/>
               </a:endParaRPr>
@@ -8773,10 +8727,290 @@
           </a:p>
         </p:txBody>
       </p:sp>
+      <p:sp>
+        <p:nvSpPr>
+          <p:cNvPr id="940" name="Card 1"/>
+          <p:cNvSpPr/>
+          <p:nvPr/>
+        </p:nvSpPr>
+        <p:spPr>
+          <a:xfrm>
+            <a:off x="2374900" y="736600"/>
+            <a:ext cx="2235200" cy="1041400"/>
+          </a:xfrm>
+          <a:prstGeom prst="roundRect">
+            <a:avLst>
+              <a:gd name="adj" fmla="val 8696"/>
+            </a:avLst>
+          </a:prstGeom>
+          <a:solidFill>
+            <a:srgbClr val="FFFFFF"/>
+          </a:solidFill>
+          <a:ln w="9525">
+            <a:noFill/>
+          </a:ln>
+        </p:spPr>
+        <p:txBody>
+          <a:bodyPr/>
+          <a:lstStyle/>
+          <a:p>
+            <a:endParaRPr lang="pt-BR"/>
+          </a:p>
+        </p:txBody>
+      </p:sp>
+      <p:sp>
+        <p:nvSpPr>
+          <p:cNvPr id="941" name="Card Label 1"/>
+          <p:cNvSpPr/>
+          <p:nvPr/>
+        </p:nvSpPr>
+        <p:spPr>
+          <a:xfrm>
+            <a:off x="2540000" y="863600"/>
+            <a:ext cx="1905000" cy="228600"/>
+          </a:xfrm>
+          <a:prstGeom prst="rect">
+            <a:avLst/>
+          </a:prstGeom>
+          <a:noFill/>
+          <a:ln/>
+        </p:spPr>
+        <p:txBody>
+          <a:bodyPr wrap="square" lIns="0" tIns="0" rIns="0" bIns="0" rtlCol="0" anchor="ctr"/>
+          <a:lstStyle/>
+          <a:p>
+            <a:pPr marL="0" indent="0">
+              <a:buNone/>
+            </a:pPr>
+            <a:r>
+              <a:rPr lang="pt-BR" sz="900" b="1" kern="0" spc="50" dirty="0">
+                <a:solidFill>
+                  <a:srgbClr val="6E7075"/>
+                </a:solidFill>
+                <a:latin typeface="Segoe UI" pitchFamily="34" charset="0"/>
+                <a:ea typeface="Segoe UI" pitchFamily="34" charset="-122"/>
+                <a:cs typeface="Segoe UI" pitchFamily="34" charset="-120"/>
+              </a:rPr>
+              <a:t>ESTADOS ATENDIDOS</a:t>
+            </a:r>
+            <a:endParaRPr lang="pt-BR" sz="900" dirty="0"/>
+          </a:p>
+        </p:txBody>
+      </p:sp>
+      <p:sp>
+        <p:nvSpPr>
+          <p:cNvPr id="942" name="Card 2"/>
+          <p:cNvSpPr/>
+          <p:nvPr/>
+        </p:nvSpPr>
+        <p:spPr>
+          <a:xfrm>
+            <a:off x="4813300" y="736600"/>
+            <a:ext cx="2235200" cy="1041400"/>
+          </a:xfrm>
+          <a:prstGeom prst="roundRect">
+            <a:avLst>
+              <a:gd name="adj" fmla="val 8696"/>
+            </a:avLst>
+          </a:prstGeom>
+          <a:solidFill>
+            <a:srgbClr val="FFFFFF"/>
+          </a:solidFill>
+          <a:ln w="9525">
+            <a:noFill/>
+          </a:ln>
+        </p:spPr>
+        <p:txBody>
+          <a:bodyPr/>
+          <a:lstStyle/>
+          <a:p>
+            <a:endParaRPr lang="pt-BR"/>
+          </a:p>
+        </p:txBody>
+      </p:sp>
+      <p:sp>
+        <p:nvSpPr>
+          <p:cNvPr id="943" name="Card Label 2"/>
+          <p:cNvSpPr/>
+          <p:nvPr/>
+        </p:nvSpPr>
+        <p:spPr>
+          <a:xfrm>
+            <a:off x="4978400" y="863600"/>
+            <a:ext cx="1905000" cy="228600"/>
+          </a:xfrm>
+          <a:prstGeom prst="rect">
+            <a:avLst/>
+          </a:prstGeom>
+          <a:noFill/>
+          <a:ln/>
+        </p:spPr>
+        <p:txBody>
+          <a:bodyPr wrap="square" lIns="0" tIns="0" rIns="0" bIns="0" rtlCol="0" anchor="ctr"/>
+          <a:lstStyle/>
+          <a:p>
+            <a:pPr marL="0" indent="0">
+              <a:buNone/>
+            </a:pPr>
+            <a:r>
+              <a:rPr lang="pt-BR" sz="900" b="1" kern="0" spc="50" dirty="0">
+                <a:solidFill>
+                  <a:srgbClr val="6E7075"/>
+                </a:solidFill>
+                <a:latin typeface="Segoe UI" pitchFamily="34" charset="0"/>
+                <a:ea typeface="Segoe UI" pitchFamily="34" charset="-122"/>
+                <a:cs typeface="Segoe UI" pitchFamily="34" charset="-120"/>
+              </a:rPr>
+              <a:t>ESTADO LÍDER EM RECEITA</a:t>
+            </a:r>
+            <a:endParaRPr lang="pt-BR" sz="900" dirty="0"/>
+          </a:p>
+        </p:txBody>
+      </p:sp>
+      <p:sp>
+        <p:nvSpPr>
+          <p:cNvPr id="944" name="Card 3"/>
+          <p:cNvSpPr/>
+          <p:nvPr/>
+        </p:nvSpPr>
+        <p:spPr>
+          <a:xfrm>
+            <a:off x="7251700" y="736600"/>
+            <a:ext cx="2235200" cy="1041400"/>
+          </a:xfrm>
+          <a:prstGeom prst="roundRect">
+            <a:avLst>
+              <a:gd name="adj" fmla="val 8696"/>
+            </a:avLst>
+          </a:prstGeom>
+          <a:solidFill>
+            <a:srgbClr val="FFFFFF"/>
+          </a:solidFill>
+          <a:ln w="9525">
+            <a:noFill/>
+          </a:ln>
+        </p:spPr>
+        <p:txBody>
+          <a:bodyPr/>
+          <a:lstStyle/>
+          <a:p>
+            <a:endParaRPr lang="pt-BR"/>
+          </a:p>
+        </p:txBody>
+      </p:sp>
+      <p:sp>
+        <p:nvSpPr>
+          <p:cNvPr id="945" name="Card Label 3"/>
+          <p:cNvSpPr/>
+          <p:nvPr/>
+        </p:nvSpPr>
+        <p:spPr>
+          <a:xfrm>
+            <a:off x="7416800" y="863600"/>
+            <a:ext cx="1905000" cy="228600"/>
+          </a:xfrm>
+          <a:prstGeom prst="rect">
+            <a:avLst/>
+          </a:prstGeom>
+          <a:noFill/>
+          <a:ln/>
+        </p:spPr>
+        <p:txBody>
+          <a:bodyPr wrap="square" lIns="0" tIns="0" rIns="0" bIns="0" rtlCol="0" anchor="ctr"/>
+          <a:lstStyle/>
+          <a:p>
+            <a:pPr marL="0" indent="0">
+              <a:buNone/>
+            </a:pPr>
+            <a:r>
+              <a:rPr lang="pt-BR" sz="900" b="1" kern="0" spc="50" dirty="0">
+                <a:solidFill>
+                  <a:srgbClr val="6E7075"/>
+                </a:solidFill>
+                <a:latin typeface="Segoe UI" pitchFamily="34" charset="0"/>
+                <a:ea typeface="Segoe UI" pitchFamily="34" charset="-122"/>
+                <a:cs typeface="Segoe UI" pitchFamily="34" charset="-120"/>
+              </a:rPr>
+              <a:t>RECEITA MÉDIA POR ESTADO</a:t>
+            </a:r>
+            <a:endParaRPr lang="pt-BR" sz="900" dirty="0"/>
+          </a:p>
+        </p:txBody>
+      </p:sp>
+      <p:sp>
+        <p:nvSpPr>
+          <p:cNvPr id="946" name="Card 4"/>
+          <p:cNvSpPr/>
+          <p:nvPr/>
+        </p:nvSpPr>
+        <p:spPr>
+          <a:xfrm>
+            <a:off x="9690100" y="736600"/>
+            <a:ext cx="2235200" cy="1041400"/>
+          </a:xfrm>
+          <a:prstGeom prst="roundRect">
+            <a:avLst>
+              <a:gd name="adj" fmla="val 8696"/>
+            </a:avLst>
+          </a:prstGeom>
+          <a:solidFill>
+            <a:srgbClr val="FFFFFF"/>
+          </a:solidFill>
+          <a:ln w="9525">
+            <a:noFill/>
+          </a:ln>
+        </p:spPr>
+        <p:txBody>
+          <a:bodyPr/>
+          <a:lstStyle/>
+          <a:p>
+            <a:endParaRPr lang="pt-BR"/>
+          </a:p>
+        </p:txBody>
+      </p:sp>
+      <p:sp>
+        <p:nvSpPr>
+          <p:cNvPr id="947" name="Card Label 4"/>
+          <p:cNvSpPr/>
+          <p:nvPr/>
+        </p:nvSpPr>
+        <p:spPr>
+          <a:xfrm>
+            <a:off x="9855200" y="863600"/>
+            <a:ext cx="1905000" cy="228600"/>
+          </a:xfrm>
+          <a:prstGeom prst="rect">
+            <a:avLst/>
+          </a:prstGeom>
+          <a:noFill/>
+          <a:ln/>
+        </p:spPr>
+        <p:txBody>
+          <a:bodyPr wrap="square" lIns="0" tIns="0" rIns="0" bIns="0" rtlCol="0" anchor="ctr"/>
+          <a:lstStyle/>
+          <a:p>
+            <a:pPr marL="0" indent="0">
+              <a:buNone/>
+            </a:pPr>
+            <a:r>
+              <a:rPr lang="pt-BR" sz="900" b="1" kern="0" spc="50" dirty="0">
+                <a:solidFill>
+                  <a:srgbClr val="6E7075"/>
+                </a:solidFill>
+                <a:latin typeface="Segoe UI" pitchFamily="34" charset="0"/>
+                <a:ea typeface="Segoe UI" pitchFamily="34" charset="-122"/>
+                <a:cs typeface="Segoe UI" pitchFamily="34" charset="-120"/>
+              </a:rPr>
+              <a:t>% RECEITA FORA DE SP</a:t>
+            </a:r>
+            <a:endParaRPr lang="pt-BR" sz="900" dirty="0"/>
+          </a:p>
+        </p:txBody>
+      </p:sp>
     </p:spTree>
     <p:extLst>
       <p:ext uri="{BB962C8B-B14F-4D97-AF65-F5344CB8AC3E}">
-        <p14:creationId xmlns:p14="http://schemas.microsoft.com/office/powerpoint/2010/main" val="4254914698"/>
+        <p14:creationId xmlns:p14="http://schemas.microsoft.com/office/powerpoint/2010/main" val="2173601608"/>
       </p:ext>
     </p:extLst>
   </p:cSld>
@@ -9401,7 +9635,7 @@
   <wetp:taskpane dockstate="right" visibility="0" width="350" row="0">
     <wetp:webextensionref xmlns:r="http://schemas.openxmlformats.org/officeDocument/2006/relationships" r:id="rId1"/>
   </wetp:taskpane>
-  <wetp:taskpane dockstate="right" visibility="0" width="350" row="1">
+  <wetp:taskpane dockstate="right" visibility="0" width="350" row="0">
     <wetp:webextensionref xmlns:r="http://schemas.openxmlformats.org/officeDocument/2006/relationships" r:id="rId2"/>
   </wetp:taskpane>
 </wetp:taskpanes>

</xml_diff>